<commit_message>
Update location of spec files
</commit_message>
<xml_diff>
--- a/AI Spec-Driven Development — Edmonton .NET User Group.pptx
+++ b/AI Spec-Driven Development — Edmonton .NET User Group.pptx
@@ -3013,7 +3013,7 @@
                 <a:ea typeface="Consolas" pitchFamily="34" charset="-122"/>
                 <a:cs typeface="Consolas" pitchFamily="34" charset="-120"/>
               </a:rPr>
-              <a:t>.ai / ARCHITECTURE.md</a:t>
+              <a:t>specs / ARCHITECTURE.md</a:t>
             </a:r>
             <a:endParaRPr lang="en-US" sz="680" dirty="0"/>
           </a:p>
@@ -7641,10 +7641,21 @@
                 <a:ea typeface="Calibri" pitchFamily="34" charset="-122"/>
                 <a:cs typeface="Calibri" pitchFamily="34" charset="-120"/>
               </a:rPr>
-              <a:t>Walk through the </a:t>
-            </a:r>
-            <a:r>
-              <a:rPr lang="en-US" sz="620" dirty="0">
+              <a:t>Walk through </a:t>
+            </a:r>
+            <a:r>
+              <a:rPr lang="en-US" sz="700">
+                <a:solidFill>
+                  <a:srgbClr val="8B949E"/>
+                </a:solidFill>
+                <a:latin typeface="Calibri" pitchFamily="34" charset="0"/>
+                <a:ea typeface="Calibri" pitchFamily="34" charset="-122"/>
+                <a:cs typeface="Calibri" pitchFamily="34" charset="-120"/>
+              </a:rPr>
+              <a:t>the </a:t>
+            </a:r>
+            <a:r>
+              <a:rPr lang="en-US" sz="620">
                 <a:solidFill>
                   <a:srgbClr val="58A6FF"/>
                 </a:solidFill>
@@ -7657,7 +7668,23 @@
                 <a:ea typeface="Consolas" pitchFamily="34" charset="-122"/>
                 <a:cs typeface="Consolas" pitchFamily="34" charset="-120"/>
               </a:rPr>
-              <a:t>.ai/</a:t>
+              <a:t>specs</a:t>
+            </a:r>
+            <a:r>
+              <a:rPr lang="en-US" sz="620" dirty="0">
+                <a:solidFill>
+                  <a:srgbClr val="58A6FF"/>
+                </a:solidFill>
+                <a:highlight>
+                  <a:srgbClr val="58A6FF">
+                    <a:alpha val="10000"/>
+                  </a:srgbClr>
+                </a:highlight>
+                <a:latin typeface="Consolas" pitchFamily="34" charset="0"/>
+                <a:ea typeface="Consolas" pitchFamily="34" charset="-122"/>
+                <a:cs typeface="Consolas" pitchFamily="34" charset="-120"/>
+              </a:rPr>
+              <a:t>/</a:t>
             </a:r>
             <a:r>
               <a:rPr lang="en-US" sz="700" dirty="0">
@@ -11534,11 +11561,10 @@
           <a:bodyPr wrap="none" lIns="0" tIns="0" rIns="0" bIns="0" rtlCol="0" anchor="ctr"/>
           <a:lstStyle/>
           <a:p>
-            <a:pPr marL="0" indent="0" algn="l">
+            <a:pPr>
               <a:lnSpc>
                 <a:spcPts val="1050"/>
               </a:lnSpc>
-              <a:buNone/>
             </a:pPr>
             <a:r>
               <a:rPr lang="en-US" sz="700" dirty="0">
@@ -11549,7 +11575,28 @@
                 <a:ea typeface="Consolas" pitchFamily="34" charset="-122"/>
                 <a:cs typeface="Consolas" pitchFamily="34" charset="-120"/>
               </a:rPr>
-              <a:t>github.com/michaelchu28</a:t>
+              <a:t>github.com/michaelchu28/</a:t>
+            </a:r>
+            <a:br>
+              <a:rPr lang="en-US" sz="700" dirty="0">
+                <a:solidFill>
+                  <a:srgbClr val="58A6FF"/>
+                </a:solidFill>
+                <a:latin typeface="Consolas" pitchFamily="34" charset="0"/>
+                <a:ea typeface="Consolas" pitchFamily="34" charset="-122"/>
+                <a:cs typeface="Consolas" pitchFamily="34" charset="-120"/>
+              </a:rPr>
+            </a:br>
+            <a:r>
+              <a:rPr lang="en-US" sz="700" dirty="0">
+                <a:solidFill>
+                  <a:srgbClr val="58A6FF"/>
+                </a:solidFill>
+                <a:latin typeface="Consolas" pitchFamily="34" charset="0"/>
+                <a:ea typeface="Consolas" pitchFamily="34" charset="-122"/>
+                <a:cs typeface="Consolas" pitchFamily="34" charset="-120"/>
+              </a:rPr>
+              <a:t>ai-spec-driven-development</a:t>
             </a:r>
             <a:endParaRPr lang="en-US" sz="700" dirty="0"/>
           </a:p>
@@ -11563,8 +11610,8 @@
         </p:nvSpPr>
         <p:spPr>
           <a:xfrm>
-            <a:off x="1273225" y="2859881"/>
-            <a:ext cx="1918508" cy="458026"/>
+            <a:off x="1273225" y="2972990"/>
+            <a:ext cx="1918508" cy="481459"/>
           </a:xfrm>
           <a:prstGeom prst="rect">
             <a:avLst/>
@@ -18312,10 +18359,26 @@
                   </a:srgbClr>
                 </a:highlight>
                 <a:latin typeface="Consolas" pitchFamily="34" charset="0"/>
+                <a:ea typeface="Calibri" pitchFamily="34" charset="-122"/>
+                <a:cs typeface="Calibri" pitchFamily="34" charset="-120"/>
+              </a:rPr>
+              <a:t>specs</a:t>
+            </a:r>
+            <a:r>
+              <a:rPr lang="en-US" sz="730" b="1" dirty="0">
+                <a:solidFill>
+                  <a:srgbClr val="58A6FF"/>
+                </a:solidFill>
+                <a:highlight>
+                  <a:srgbClr val="58A6FF">
+                    <a:alpha val="10000"/>
+                  </a:srgbClr>
+                </a:highlight>
+                <a:latin typeface="Consolas" pitchFamily="34" charset="0"/>
                 <a:ea typeface="Consolas" pitchFamily="34" charset="-122"/>
                 <a:cs typeface="Consolas" pitchFamily="34" charset="-120"/>
               </a:rPr>
-              <a:t>.ai/architecture.md</a:t>
+              <a:t>/architecture.md</a:t>
             </a:r>
             <a:endParaRPr lang="en-US" sz="900" dirty="0"/>
           </a:p>
@@ -20661,7 +20724,7 @@
                 <a:ea typeface="Consolas" pitchFamily="34" charset="-122"/>
                 <a:cs typeface="Consolas" pitchFamily="34" charset="-120"/>
               </a:rPr>
-              <a:t>.ai/architecture.md</a:t>
+              <a:t>specs/architecture.md</a:t>
             </a:r>
             <a:endParaRPr lang="en-US" sz="730" dirty="0"/>
           </a:p>
@@ -21721,7 +21784,7 @@
                 <a:ea typeface="Consolas" pitchFamily="34" charset="-122"/>
                 <a:cs typeface="Consolas" pitchFamily="34" charset="-120"/>
               </a:rPr>
-              <a:t>.ai/</a:t>
+              <a:t>specs/</a:t>
             </a:r>
             <a:endParaRPr lang="en-US" sz="680" dirty="0"/>
           </a:p>
@@ -24261,7 +24324,7 @@
                 <a:ea typeface="Calibri" pitchFamily="34" charset="-122"/>
                 <a:cs typeface="Calibri" pitchFamily="34" charset="-120"/>
               </a:rPr>
-              <a:t>Stored in .ai/ folder at the repo root, versioned with the code.</a:t>
+              <a:t>Stored in specs/ folder at the repo root, versioned with the code.</a:t>
             </a:r>
             <a:endParaRPr lang="en-US" sz="1200" dirty="0"/>
           </a:p>
@@ -25317,7 +25380,7 @@
                 <a:ea typeface="Consolas" pitchFamily="34" charset="-122"/>
                 <a:cs typeface="Consolas" pitchFamily="34" charset="-120"/>
               </a:rPr>
-              <a:t>.ai/</a:t>
+              <a:t>.specs/</a:t>
             </a:r>
             <a:endParaRPr lang="en-US" sz="790" dirty="0"/>
           </a:p>
@@ -29328,7 +29391,7 @@
                 <a:ea typeface="Consolas" pitchFamily="34" charset="-122"/>
                 <a:cs typeface="Consolas" pitchFamily="34" charset="-120"/>
               </a:rPr>
-              <a:t>.ai/ARCHITECTURE.md</a:t>
+              <a:t>specs/ARCHITECTURE.md</a:t>
             </a:r>
             <a:r>
               <a:rPr lang="en-US" sz="1100" dirty="0">
@@ -29355,7 +29418,7 @@
                 <a:ea typeface="Consolas" pitchFamily="34" charset="-122"/>
                 <a:cs typeface="Consolas" pitchFamily="34" charset="-120"/>
               </a:rPr>
-              <a:t>.ai/[FEATURE].md</a:t>
+              <a:t>specs/feature/[FEATURE].md</a:t>
             </a:r>
             <a:r>
               <a:rPr lang="en-US" sz="1100" dirty="0">

</xml_diff>